<commit_message>
Taxonomy answer document for the client (rules, algorithm, EN/RU, combinations); rule fixes: English 'will' and payroll; correct subtopic count to 72; report and decks rebuilt
Co-Authored-By: Claude Sonnet 5.5 <noreply@anthropic.com>
</commit_message>
<xml_diff>
--- a/data/leads/informe-leads-es.pptx
+++ b/data/leads/informe-leads-es.pptx
@@ -655,7 +655,7 @@
                   <c:v>11.9</c:v>
                 </c:pt>
                 <c:pt idx="3">
-                  <c:v>9.3</c:v>
+                  <c:v>8.6</c:v>
                 </c:pt>
                 <c:pt idx="4">
                   <c:v>7.5</c:v>
@@ -829,7 +829,7 @@
                 <c:formatCode>General</c:formatCode>
                 <c:ptCount val="3"/>
                 <c:pt idx="0">
-                  <c:v>19.5</c:v>
+                  <c:v>19.6</c:v>
                 </c:pt>
                 <c:pt idx="1">
                   <c:v>11.1</c:v>
@@ -884,7 +884,7 @@
                 <c:formatCode>General</c:formatCode>
                 <c:ptCount val="3"/>
                 <c:pt idx="0">
-                  <c:v>20.7</c:v>
+                  <c:v>20.4</c:v>
                 </c:pt>
                 <c:pt idx="1">
                   <c:v>18.1</c:v>
@@ -1049,7 +1049,7 @@
                 <c:formatCode>General</c:formatCode>
                 <c:ptCount val="3"/>
                 <c:pt idx="0">
-                  <c:v>4.1</c:v>
+                  <c:v>4.2</c:v>
                 </c:pt>
                 <c:pt idx="1">
                   <c:v>5.2</c:v>
@@ -1104,7 +1104,7 @@
                 <c:formatCode>General</c:formatCode>
                 <c:ptCount val="3"/>
                 <c:pt idx="0">
-                  <c:v>26.6</c:v>
+                  <c:v>26.7</c:v>
                 </c:pt>
                 <c:pt idx="1">
                   <c:v>29.8</c:v>
@@ -2450,22 +2450,22 @@
               <c:strCache>
                 <c:ptCount val="6"/>
                 <c:pt idx="0">
+                  <c:v>Escritura, notaría y registro de la propiedad</c:v>
+                </c:pt>
+                <c:pt idx="1">
+                  <c:v>Convenio de doble imposición / residencia fiscal</c:v>
+                </c:pt>
+                <c:pt idx="2">
                   <c:v>Herencia, testamento y declaración de herederos</c:v>
                 </c:pt>
-                <c:pt idx="1">
-                  <c:v>Escritura, notaría y registro de la propiedad</c:v>
-                </c:pt>
-                <c:pt idx="2">
-                  <c:v>IVA, contabilidad, gestoría e impuesto de sociedades</c:v>
-                </c:pt>
                 <c:pt idx="3">
-                  <c:v>Convenio de doble imposición / residencia fiscal</c:v>
+                  <c:v>Visado consular</c:v>
                 </c:pt>
                 <c:pt idx="4">
-                  <c:v>Visado consular</c:v>
+                  <c:v>Compra de vivienda / inmueble</c:v>
                 </c:pt>
                 <c:pt idx="5">
-                  <c:v>Compra de vivienda / inmueble</c:v>
+                  <c:v>IVA, contabilidad, gestoría e impuesto de sociedades</c:v>
                 </c:pt>
               </c:strCache>
             </c:strRef>
@@ -2477,22 +2477,22 @@
                 <c:formatCode>General</c:formatCode>
                 <c:ptCount val="6"/>
                 <c:pt idx="0">
-                  <c:v>11.9</c:v>
+                  <c:v>11.5</c:v>
                 </c:pt>
                 <c:pt idx="1">
-                  <c:v>11.5</c:v>
+                  <c:v>10.2</c:v>
                 </c:pt>
                 <c:pt idx="2">
-                  <c:v>10.7</c:v>
+                  <c:v>9.8</c:v>
                 </c:pt>
                 <c:pt idx="3">
-                  <c:v>10.2</c:v>
+                  <c:v>8.6</c:v>
                 </c:pt>
                 <c:pt idx="4">
                   <c:v>8.6</c:v>
                 </c:pt>
                 <c:pt idx="5">
-                  <c:v>8.6</c:v>
+                  <c:v>8.2</c:v>
                 </c:pt>
               </c:numCache>
             </c:numRef>
@@ -2558,7 +2558,7 @@
       <c:valAx>
         <c:axId val="-2113994440"/>
         <c:scaling>
-          <c:max val="14.875"/>
+          <c:max val="14.375"/>
         </c:scaling>
         <c:delete/>
         <c:axPos val="b"/>
@@ -7121,7 +7121,7 @@
                           </a:solidFill>
                           <a:latin typeface="Calibri"/>
                         </a:rPr>
-                        <a:t>Herencia, testamento y declaración de herederos</a:t>
+                        <a:t>NIE y TIE (tarjeta)</a:t>
                       </a:r>
                     </a:p>
                   </a:txBody>
@@ -7144,7 +7144,7 @@
                           </a:solidFill>
                           <a:latin typeface="Calibri"/>
                         </a:rPr>
-                        <a:t>7,8 %</a:t>
+                        <a:t>12,7 %</a:t>
                       </a:r>
                     </a:p>
                   </a:txBody>
@@ -7167,7 +7167,7 @@
                           </a:solidFill>
                           <a:latin typeface="Calibri"/>
                         </a:rPr>
-                        <a:t>13,0 %</a:t>
+                        <a:t>7,3 %</a:t>
                       </a:r>
                     </a:p>
                   </a:txBody>
@@ -7190,7 +7190,7 @@
                           </a:solidFill>
                           <a:latin typeface="Calibri"/>
                         </a:rPr>
-                        <a:t>11,6 %</a:t>
+                        <a:t>9,5 %</a:t>
                       </a:r>
                     </a:p>
                   </a:txBody>
@@ -7214,7 +7214,7 @@
                           </a:solidFill>
                           <a:latin typeface="Calibri"/>
                         </a:rPr>
-                        <a:t>NIE y TIE (tarjeta)</a:t>
+                        <a:t>Crear una sociedad / abrir un negocio</a:t>
                       </a:r>
                     </a:p>
                   </a:txBody>
@@ -7237,7 +7237,7 @@
                           </a:solidFill>
                           <a:latin typeface="Calibri"/>
                         </a:rPr>
-                        <a:t>12,7 %</a:t>
+                        <a:t>9,9 %</a:t>
                       </a:r>
                     </a:p>
                   </a:txBody>
@@ -7260,7 +7260,7 @@
                           </a:solidFill>
                           <a:latin typeface="Calibri"/>
                         </a:rPr>
-                        <a:t>7,3 %</a:t>
+                        <a:t>9,6 %</a:t>
                       </a:r>
                     </a:p>
                   </a:txBody>
@@ -7283,7 +7283,7 @@
                           </a:solidFill>
                           <a:latin typeface="Calibri"/>
                         </a:rPr>
-                        <a:t>9,5 %</a:t>
+                        <a:t>12,1 %</a:t>
                       </a:r>
                     </a:p>
                   </a:txBody>
@@ -7307,7 +7307,7 @@
                           </a:solidFill>
                           <a:latin typeface="Calibri"/>
                         </a:rPr>
-                        <a:t>Crear una sociedad / abrir un negocio</a:t>
+                        <a:t>Herencia, testamento y declaración de herederos</a:t>
                       </a:r>
                     </a:p>
                   </a:txBody>
@@ -7330,7 +7330,7 @@
                           </a:solidFill>
                           <a:latin typeface="Calibri"/>
                         </a:rPr>
-                        <a:t>9,9 %</a:t>
+                        <a:t>7,2 %</a:t>
                       </a:r>
                     </a:p>
                   </a:txBody>
@@ -7353,7 +7353,7 @@
                           </a:solidFill>
                           <a:latin typeface="Calibri"/>
                         </a:rPr>
-                        <a:t>9,6 %</a:t>
+                        <a:t>11,3 %</a:t>
                       </a:r>
                     </a:p>
                   </a:txBody>
@@ -7376,7 +7376,7 @@
                           </a:solidFill>
                           <a:latin typeface="Calibri"/>
                         </a:rPr>
-                        <a:t>12,1 %</a:t>
+                        <a:t>10,1 %</a:t>
                       </a:r>
                     </a:p>
                   </a:txBody>
@@ -7400,7 +7400,7 @@
                           </a:solidFill>
                           <a:latin typeface="Calibri"/>
                         </a:rPr>
-                        <a:t>IVA, contabilidad, gestoría e impuesto de sociedades</a:t>
+                        <a:t>Escritura, notaría y registro de la propiedad</a:t>
                       </a:r>
                     </a:p>
                   </a:txBody>
@@ -7423,7 +7423,7 @@
                           </a:solidFill>
                           <a:latin typeface="Calibri"/>
                         </a:rPr>
-                        <a:t>4,8 %</a:t>
+                        <a:t>3,9 %</a:t>
                       </a:r>
                     </a:p>
                   </a:txBody>
@@ -7446,7 +7446,7 @@
                           </a:solidFill>
                           <a:latin typeface="Calibri"/>
                         </a:rPr>
-                        <a:t>7,3 %</a:t>
+                        <a:t>4,0 %</a:t>
                       </a:r>
                     </a:p>
                   </a:txBody>
@@ -7469,7 +7469,7 @@
                           </a:solidFill>
                           <a:latin typeface="Calibri"/>
                         </a:rPr>
-                        <a:t>10,6 %</a:t>
+                        <a:t>8,0 %</a:t>
                       </a:r>
                     </a:p>
                   </a:txBody>
@@ -7493,7 +7493,7 @@
                           </a:solidFill>
                           <a:latin typeface="Calibri"/>
                         </a:rPr>
-                        <a:t>Escritura, notaría y registro de la propiedad</a:t>
+                        <a:t>IVA, contabilidad, gestoría e impuesto de sociedades</a:t>
                       </a:r>
                     </a:p>
                   </a:txBody>
@@ -7516,7 +7516,7 @@
                           </a:solidFill>
                           <a:latin typeface="Calibri"/>
                         </a:rPr>
-                        <a:t>3,9 %</a:t>
+                        <a:t>4,8 %</a:t>
                       </a:r>
                     </a:p>
                   </a:txBody>
@@ -7539,7 +7539,7 @@
                           </a:solidFill>
                           <a:latin typeface="Calibri"/>
                         </a:rPr>
-                        <a:t>4,0 %</a:t>
+                        <a:t>7,3 %</a:t>
                       </a:r>
                     </a:p>
                   </a:txBody>
@@ -7562,7 +7562,7 @@
                           </a:solidFill>
                           <a:latin typeface="Calibri"/>
                         </a:rPr>
-                        <a:t>8,0 %</a:t>
+                        <a:t>7,5 %</a:t>
                       </a:r>
                     </a:p>
                   </a:txBody>
@@ -8007,7 +8007,7 @@
                 </a:solidFill>
                 <a:latin typeface="Calibri"/>
               </a:rPr>
-              <a:t>Instalación y vida en España (extranjería) · Las cuatro hojas de extranjería suman 431 menciones. Propuesta de rutas para EXT-4: (1) visados de residencia: nómada digital, no lucrativa, trabajo, emprendedor; (2) reagrupación y familia; (3) nacionalidad y regularización; (4) denegaciones, requerimientos y recursos; (5) estancia irregular y 90 días. NIE y TIE, hoy el subtema más pedido, encaja mejor con la hoja de instalación (EXT-1).</a:t>
+              <a:t>Instalación y vida en España (extranjería) · Las cuatro hojas de extranjería suman 432 menciones. Propuesta de rutas para EXT-4: (1) visados de residencia: nómada digital, no lucrativa, trabajo, emprendedor; (2) reagrupación y familia; (3) nacionalidad y regularización; (4) denegaciones, requerimientos y recursos; (5) estancia irregular y 90 días. NIE y TIE, hoy el subtema más pedido, encaja mejor con la hoja de instalación (EXT-1).</a:t>
             </a:r>
           </a:p>
         </p:txBody>
@@ -8533,7 +8533,7 @@
                           </a:solidFill>
                           <a:latin typeface="Calibri"/>
                         </a:rPr>
-                        <a:t>306</a:t>
+                        <a:t>307</a:t>
                       </a:r>
                     </a:p>
                   </a:txBody>
@@ -8556,7 +8556,7 @@
                           </a:solidFill>
                           <a:latin typeface="Calibri"/>
                         </a:rPr>
-                        <a:t>207</a:t>
+                        <a:t>209</a:t>
                       </a:r>
                     </a:p>
                   </a:txBody>
@@ -8579,7 +8579,7 @@
                           </a:solidFill>
                           <a:latin typeface="Calibri"/>
                         </a:rPr>
-                        <a:t>93 · 28 · 185</a:t>
+                        <a:t>94 · 28 · 185</a:t>
                       </a:r>
                     </a:p>
                   </a:txBody>
@@ -8875,7 +8875,7 @@
                 </a:solidFill>
                 <a:latin typeface="Calibri"/>
               </a:rPr>
-              <a:t>Fiscalidad y contabilidad · FIS-2 recibe 168 menciones y se reparte en IVA y contabilidad, declaración de la renta, no residentes (Modelo 210), Beckham, Modelo 720 y plusvalías. FIS-1 (convenio y residencia fiscal) aparece en 62.</a:t>
+              <a:t>Fiscalidad y contabilidad · FIS-2 recibe 163 menciones y se reparte en IVA y contabilidad, declaración de la renta, no residentes (Modelo 210), Beckham, Modelo 720 y plusvalías. FIS-1 (convenio y residencia fiscal) aparece en 62.</a:t>
             </a:r>
           </a:p>
         </p:txBody>
@@ -9079,7 +9079,7 @@
                           </a:solidFill>
                           <a:latin typeface="Calibri"/>
                         </a:rPr>
-                        <a:t>28</a:t>
+                        <a:t>29</a:t>
                       </a:r>
                     </a:p>
                   </a:txBody>
@@ -9171,7 +9171,7 @@
                           </a:solidFill>
                           <a:latin typeface="Calibri"/>
                         </a:rPr>
-                        <a:t>168</a:t>
+                        <a:t>163</a:t>
                       </a:r>
                     </a:p>
                   </a:txBody>
@@ -9194,7 +9194,7 @@
                           </a:solidFill>
                           <a:latin typeface="Calibri"/>
                         </a:rPr>
-                        <a:t>98</a:t>
+                        <a:t>99</a:t>
                       </a:r>
                     </a:p>
                   </a:txBody>
@@ -9217,7 +9217,7 @@
                           </a:solidFill>
                           <a:latin typeface="Calibri"/>
                         </a:rPr>
-                        <a:t>63 · 7 · 98</a:t>
+                        <a:t>58 · 7 · 98</a:t>
                       </a:r>
                     </a:p>
                   </a:txBody>
@@ -9239,7 +9239,7 @@
                           </a:solidFill>
                           <a:latin typeface="Calibri"/>
                         </a:rPr>
-                        <a:t>IVA, contabilidad, gestoría e impuesto de sociedades 50 · Declaración de la renta (IRPF) 45 · Fiscalidad (consulta general) 31 · No residentes (Modelo 210 / IRNR) 23</a:t>
+                        <a:t>Declaración de la renta (IRPF) 45 · IVA, contabilidad, gestoría e impuesto de sociedades 44 · Fiscalidad (consulta general) 31 · No residentes (Modelo 210 / IRNR) 23</a:t>
                       </a:r>
                     </a:p>
                   </a:txBody>
@@ -9926,7 +9926,7 @@
                 </a:solidFill>
                 <a:latin typeface="Calibri"/>
               </a:rPr>
-              <a:t>Derecho de sucesiones y litigios · Herencias y testamentos (72) y familia (20) no tienen hoja; mediación y litigios recibe 24.</a:t>
+              <a:t>Derecho de sucesiones y litigios · Herencias y testamentos (64) y familia (20) no tienen hoja; mediación y litigios recibe 24.</a:t>
             </a:r>
           </a:p>
         </p:txBody>
@@ -10107,7 +10107,7 @@
                           </a:solidFill>
                           <a:latin typeface="Calibri"/>
                         </a:rPr>
-                        <a:t>72</a:t>
+                        <a:t>64</a:t>
                       </a:r>
                     </a:p>
                   </a:txBody>
@@ -10130,7 +10130,7 @@
                           </a:solidFill>
                           <a:latin typeface="Calibri"/>
                         </a:rPr>
-                        <a:t>49</a:t>
+                        <a:t>44</a:t>
                       </a:r>
                     </a:p>
                   </a:txBody>
@@ -10153,7 +10153,7 @@
                           </a:solidFill>
                           <a:latin typeface="Calibri"/>
                         </a:rPr>
-                        <a:t>29 · 0 · 43</a:t>
+                        <a:t>24 · 0 · 40</a:t>
                       </a:r>
                     </a:p>
                   </a:txBody>
@@ -10175,7 +10175,7 @@
                           </a:solidFill>
                           <a:latin typeface="Calibri"/>
                         </a:rPr>
-                        <a:t>Herencia, testamento y declaración de herederos 72</a:t>
+                        <a:t>Herencia, testamento y declaración de herederos 64</a:t>
                       </a:r>
                     </a:p>
                   </a:txBody>
@@ -12461,7 +12461,7 @@
                           </a:solidFill>
                           <a:latin typeface="Calibri"/>
                         </a:rPr>
-                        <a:t>14</a:t>
+                        <a:t>13</a:t>
                       </a:r>
                     </a:p>
                   </a:txBody>
@@ -12783,7 +12783,7 @@
                           </a:solidFill>
                           <a:latin typeface="Calibri"/>
                         </a:rPr>
-                        <a:t>Convenio de doble imposición / residencia fiscal + IVA, contabilidad, gestoría e impuesto de sociedades</a:t>
+                        <a:t>NIE y TIE (tarjeta) + IVA, contabilidad, gestoría e impuesto de sociedades</a:t>
                       </a:r>
                     </a:p>
                   </a:txBody>
@@ -12828,7 +12828,7 @@
                           </a:solidFill>
                           <a:latin typeface="Calibri"/>
                         </a:rPr>
-                        <a:t>Fiscalidad de empresa y expatriado</a:t>
+                        <a:t>Llegada y autónomo</a:t>
                       </a:r>
                     </a:p>
                   </a:txBody>
@@ -12852,7 +12852,7 @@
                           </a:solidFill>
                           <a:latin typeface="Calibri"/>
                         </a:rPr>
-                        <a:t>NIE y TIE (tarjeta) + IVA, contabilidad, gestoría e impuesto de sociedades</a:t>
+                        <a:t>NIE y TIE (tarjeta) + Compra de vivienda / inmueble</a:t>
                       </a:r>
                     </a:p>
                   </a:txBody>
@@ -12875,7 +12875,7 @@
                           </a:solidFill>
                           <a:latin typeface="Calibri"/>
                         </a:rPr>
-                        <a:t>11</a:t>
+                        <a:t>10</a:t>
                       </a:r>
                     </a:p>
                   </a:txBody>
@@ -12897,7 +12897,7 @@
                           </a:solidFill>
                           <a:latin typeface="Calibri"/>
                         </a:rPr>
-                        <a:t>Llegada y autónomo</a:t>
+                        <a:t>Comprar y residir</a:t>
                       </a:r>
                     </a:p>
                   </a:txBody>
@@ -12921,7 +12921,7 @@
                           </a:solidFill>
                           <a:latin typeface="Calibri"/>
                         </a:rPr>
-                        <a:t>NIE y TIE (tarjeta) + Compra de vivienda / inmueble</a:t>
+                        <a:t>IVA, contabilidad, gestoría e impuesto de sociedades + Alta de autónomo / freelance / auto-entrepreneur</a:t>
                       </a:r>
                     </a:p>
                   </a:txBody>
@@ -12966,7 +12966,7 @@
                           </a:solidFill>
                           <a:latin typeface="Calibri"/>
                         </a:rPr>
-                        <a:t>Comprar y residir</a:t>
+                        <a:t>Autónomo y gestoría</a:t>
                       </a:r>
                     </a:p>
                   </a:txBody>
@@ -12990,7 +12990,7 @@
                           </a:solidFill>
                           <a:latin typeface="Calibri"/>
                         </a:rPr>
-                        <a:t>IVA, contabilidad, gestoría e impuesto de sociedades + Alta de autónomo / freelance / auto-entrepreneur</a:t>
+                        <a:t>Convenio de doble imposición / residencia fiscal + IVA, contabilidad, gestoría e impuesto de sociedades</a:t>
                       </a:r>
                     </a:p>
                   </a:txBody>
@@ -13035,7 +13035,7 @@
                           </a:solidFill>
                           <a:latin typeface="Calibri"/>
                         </a:rPr>
-                        <a:t>Autónomo y gestoría</a:t>
+                        <a:t>Fiscalidad de empresa y expatriado</a:t>
                       </a:r>
                     </a:p>
                   </a:txBody>
@@ -14549,7 +14549,7 @@
                 </a:solidFill>
                 <a:latin typeface="Calibri"/>
               </a:rPr>
-              <a:t>259 solicitudes · 36 % solo información</a:t>
+              <a:t>260 solicitudes · 35 % solo información</a:t>
             </a:r>
           </a:p>
         </p:txBody>
@@ -14865,7 +14865,7 @@
                 </a:solidFill>
                 <a:latin typeface="Calibri"/>
               </a:rPr>
-              <a:t>198 solicitudes · 35 % solo información</a:t>
+              <a:t>193 solicitudes · 35 % solo información</a:t>
             </a:r>
           </a:p>
         </p:txBody>
@@ -16306,7 +16306,7 @@
                 </a:solidFill>
                 <a:latin typeface="Calibri"/>
               </a:rPr>
-              <a:t>104 solicitudes · 33 % solo información</a:t>
+              <a:t>96 solicitudes · 34 % solo información</a:t>
             </a:r>
           </a:p>
         </p:txBody>
@@ -18160,7 +18160,7 @@
                 </a:solidFill>
                 <a:latin typeface="Calibri"/>
               </a:rPr>
-              <a:t>72 solicitudes (10 % de las analizadas) hablan de herencia. La web solo la cubre dentro de «Sucesiones y planificación patrimonial», bajo Fiscalidad. Divorcio, custodia y adopción (20) tampoco tienen lugar en el árbol.</a:t>
+              <a:t>64 solicitudes (9 % de las analizadas) hablan de herencia. La web solo la cubre dentro de «Sucesiones y planificación patrimonial», bajo Fiscalidad. Divorcio, custodia y adopción (20) tampoco tienen lugar en el árbol.</a:t>
             </a:r>
           </a:p>
         </p:txBody>
@@ -21400,7 +21400,7 @@
                 </a:solidFill>
                 <a:latin typeface="Calibri"/>
               </a:rPr>
-              <a:t>• Clasificación: reglas multilingües (ES, FR, EN) sobre asunto y mensaje, con 62 subtemas asignados a las 17 hojas de dlvibe y 3 propuestas. Se revisó a mano una muestra de 24 casos: el tema principal es razonable en la mayoría y las etiquetas secundarias tienen más ruido.</a:t>
+              <a:t>• Clasificación: reglas multilingües (ES, FR, EN) sobre asunto y mensaje, con 72 subtemas asignados a las 17 hojas de dlvibe y 3 propuestas. Se revisó a mano una muestra de 24 casos: el tema principal es razonable en la mayoría y las etiquetas secundarias tienen más ruido.</a:t>
             </a:r>
           </a:p>
           <a:p>
@@ -24910,7 +24910,7 @@
                           </a:solidFill>
                           <a:latin typeface="Calibri"/>
                         </a:rPr>
-                        <a:t>78 (32 %)</a:t>
+                        <a:t>80 (33 %)</a:t>
                       </a:r>
                     </a:p>
                   </a:txBody>
@@ -25072,7 +25072,7 @@
                           </a:solidFill>
                           <a:latin typeface="Calibri"/>
                         </a:rPr>
-                        <a:t>48 (20 %)</a:t>
+                        <a:t>50 (20 %)</a:t>
                       </a:r>
                     </a:p>
                   </a:txBody>
@@ -25396,7 +25396,7 @@
                           </a:solidFill>
                           <a:latin typeface="Calibri"/>
                         </a:rPr>
-                        <a:t>24 (10 %)</a:t>
+                        <a:t>19 (8 %)</a:t>
                       </a:r>
                     </a:p>
                   </a:txBody>
@@ -25882,7 +25882,7 @@
                           </a:solidFill>
                           <a:latin typeface="Calibri"/>
                         </a:rPr>
-                        <a:t>4 (2 %)</a:t>
+                        <a:t>5 (2 %)</a:t>
                       </a:r>
                     </a:p>
                   </a:txBody>

</xml_diff>